<commit_message>
docs(examples): make the twin-output snippet self-contained and true the README's PPTX claims
</commit_message>
<xml_diff>
--- a/assets/readme/examples/twin-output.pptx
+++ b/assets/readme/examples/twin-output.pptx
@@ -3494,12 +3494,12 @@
         </p:nvSpPr>
         <p:spPr>
           <a:xfrm>
-            <a:off x="660400" y="3759200"/>
-            <a:ext cx="5969000" cy="1879600"/>
+            <a:off x="660400" y="3708400"/>
+            <a:ext cx="5969000" cy="1930400"/>
           </a:xfrm>
           <a:prstGeom prst="roundRect">
             <a:avLst>
-              <a:gd name="adj" fmla="val 9459"/>
+              <a:gd name="adj" fmla="val 9211"/>
             </a:avLst>
           </a:prstGeom>
           <a:solidFill>
@@ -3522,7 +3522,53 @@
         </p:nvSpPr>
         <p:spPr>
           <a:xfrm>
-            <a:off x="914400" y="3912445"/>
+            <a:off x="914400" y="3836245"/>
+            <a:ext cx="2896870" cy="94831"/>
+          </a:xfrm>
+          <a:prstGeom prst="rect">
+            <a:avLst/>
+          </a:prstGeom>
+        </p:spPr>
+        <p:txBody>
+          <a:bodyPr anchor="t" rtlCol="false" wrap="none" tIns="0" rIns="0" bIns="0" lIns="0">
+            <a:noAutofit/>
+          </a:bodyPr>
+          <a:lstStyle/>
+          <a:p>
+            <a:pPr algn="l">
+              <a:lnSpc>
+                <a:spcPct val="100000"/>
+              </a:lnSpc>
+              <a:spcBef>
+                <a:spcPct val="0"/>
+              </a:spcBef>
+              <a:spcAft>
+                <a:spcPct val="0"/>
+              </a:spcAft>
+              <a:defRPr/>
+            </a:pPr>
+            <a:r>
+              <a:rPr lang="en-US" sz="950" b="false" i="false" u="none" strike="noStrike" kern="0">
+                <a:solidFill>
+                  <a:srgbClr val="BEC3D6"/>
+                </a:solidFill>
+                <a:latin typeface="Courier New"/>
+              </a:rPr>
+              <a:t>Path deck = Path.of("twin-output.pptx");</a:t>
+            </a:r>
+            <a:endParaRPr lang="en-US" sz="1100"/>
+          </a:p>
+        </p:txBody>
+      </p:sp>
+      <p:sp>
+        <p:nvSpPr>
+          <p:cNvPr name="GraphCompose Text Line" id="16"/>
+          <p:cNvSpPr txBox="true"/>
+          <p:nvPr/>
+        </p:nvSpPr>
+        <p:spPr>
+          <a:xfrm>
+            <a:off x="914400" y="4021665"/>
             <a:ext cx="2824480" cy="94831"/>
           </a:xfrm>
           <a:prstGeom prst="rect">
@@ -3562,13 +3608,13 @@
       </p:sp>
       <p:sp>
         <p:nvSpPr>
-          <p:cNvPr name="GraphCompose Text Line" id="16"/>
+          <p:cNvPr name="GraphCompose Text Line" id="17"/>
           <p:cNvSpPr txBox="true"/>
           <p:nvPr/>
         </p:nvSpPr>
         <p:spPr>
           <a:xfrm>
-            <a:off x="1371600" y="4109295"/>
+            <a:off x="1371600" y="4207085"/>
             <a:ext cx="2679700" cy="94831"/>
           </a:xfrm>
           <a:prstGeom prst="rect">
@@ -3608,13 +3654,13 @@
       </p:sp>
       <p:sp>
         <p:nvSpPr>
-          <p:cNvPr name="GraphCompose Text Line" id="17"/>
+          <p:cNvPr name="GraphCompose Text Line" id="18"/>
           <p:cNvSpPr txBox="true"/>
           <p:nvPr/>
         </p:nvSpPr>
         <p:spPr>
           <a:xfrm>
-            <a:off x="1371600" y="4306145"/>
+            <a:off x="1371600" y="4392505"/>
             <a:ext cx="2752090" cy="94831"/>
           </a:xfrm>
           <a:prstGeom prst="rect">
@@ -3654,13 +3700,13 @@
       </p:sp>
       <p:sp>
         <p:nvSpPr>
-          <p:cNvPr name="GraphCompose Text Line" id="18"/>
+          <p:cNvPr name="GraphCompose Text Line" id="19"/>
           <p:cNvSpPr txBox="true"/>
           <p:nvPr/>
         </p:nvSpPr>
         <p:spPr>
           <a:xfrm>
-            <a:off x="1371600" y="4502995"/>
+            <a:off x="1371600" y="4577925"/>
             <a:ext cx="869950" cy="94831"/>
           </a:xfrm>
           <a:prstGeom prst="rect">
@@ -3700,13 +3746,13 @@
       </p:sp>
       <p:sp>
         <p:nvSpPr>
-          <p:cNvPr name="GraphCompose Text Line" id="19"/>
+          <p:cNvPr name="GraphCompose Text Line" id="20"/>
           <p:cNvSpPr txBox="true"/>
           <p:nvPr/>
         </p:nvSpPr>
         <p:spPr>
           <a:xfrm>
-            <a:off x="1143000" y="4699845"/>
+            <a:off x="1143000" y="4763345"/>
             <a:ext cx="942340" cy="94831"/>
           </a:xfrm>
           <a:prstGeom prst="rect">
@@ -3746,13 +3792,13 @@
       </p:sp>
       <p:sp>
         <p:nvSpPr>
-          <p:cNvPr name="GraphCompose Text Line" id="20"/>
+          <p:cNvPr name="GraphCompose Text Line" id="21"/>
           <p:cNvSpPr txBox="true"/>
           <p:nvPr/>
         </p:nvSpPr>
         <p:spPr>
           <a:xfrm>
-            <a:off x="3835400" y="4699845"/>
+            <a:off x="3835400" y="4763345"/>
             <a:ext cx="1304290" cy="94831"/>
           </a:xfrm>
           <a:prstGeom prst="rect">
@@ -3792,13 +3838,13 @@
       </p:sp>
       <p:sp>
         <p:nvSpPr>
-          <p:cNvPr name="GraphCompose Text Line" id="21"/>
+          <p:cNvPr name="GraphCompose Text Line" id="22"/>
           <p:cNvSpPr txBox="true"/>
           <p:nvPr/>
         </p:nvSpPr>
         <p:spPr>
           <a:xfrm>
-            <a:off x="1143000" y="4896695"/>
+            <a:off x="1143000" y="4948765"/>
             <a:ext cx="1087120" cy="94831"/>
           </a:xfrm>
           <a:prstGeom prst="rect">
@@ -3838,13 +3884,13 @@
       </p:sp>
       <p:sp>
         <p:nvSpPr>
-          <p:cNvPr name="GraphCompose Text Line" id="22"/>
+          <p:cNvPr name="GraphCompose Text Line" id="23"/>
           <p:cNvSpPr txBox="true"/>
           <p:nvPr/>
         </p:nvSpPr>
         <p:spPr>
           <a:xfrm>
-            <a:off x="3835400" y="4896695"/>
+            <a:off x="3835400" y="4948765"/>
             <a:ext cx="1304290" cy="94831"/>
           </a:xfrm>
           <a:prstGeom prst="rect">
@@ -3884,13 +3930,13 @@
       </p:sp>
       <p:sp>
         <p:nvSpPr>
-          <p:cNvPr name="GraphCompose Text Line" id="23"/>
+          <p:cNvPr name="GraphCompose Text Line" id="24"/>
           <p:cNvSpPr txBox="true"/>
           <p:nvPr/>
         </p:nvSpPr>
         <p:spPr>
           <a:xfrm>
-            <a:off x="1143000" y="5093545"/>
+            <a:off x="1143000" y="5134185"/>
             <a:ext cx="1449070" cy="94831"/>
           </a:xfrm>
           <a:prstGeom prst="rect">
@@ -3930,13 +3976,13 @@
       </p:sp>
       <p:sp>
         <p:nvSpPr>
-          <p:cNvPr name="GraphCompose Text Line" id="24"/>
+          <p:cNvPr name="GraphCompose Text Line" id="25"/>
           <p:cNvSpPr txBox="true"/>
           <p:nvPr/>
         </p:nvSpPr>
         <p:spPr>
           <a:xfrm>
-            <a:off x="3835400" y="5093545"/>
+            <a:off x="3835400" y="5134185"/>
             <a:ext cx="1593850" cy="94831"/>
           </a:xfrm>
           <a:prstGeom prst="rect">
@@ -3976,13 +4022,13 @@
       </p:sp>
       <p:sp>
         <p:nvSpPr>
-          <p:cNvPr name="GraphCompose Text Line" id="25"/>
+          <p:cNvPr name="GraphCompose Text Line" id="26"/>
           <p:cNvSpPr txBox="true"/>
           <p:nvPr/>
         </p:nvSpPr>
         <p:spPr>
           <a:xfrm>
-            <a:off x="914400" y="5290395"/>
+            <a:off x="914400" y="5319605"/>
             <a:ext cx="73660" cy="94831"/>
           </a:xfrm>
           <a:prstGeom prst="rect">
@@ -4022,7 +4068,7 @@
       </p:sp>
       <p:sp>
         <p:nvSpPr>
-          <p:cNvPr name="GraphCompose Text Line" id="26"/>
+          <p:cNvPr name="GraphCompose Text Line" id="27"/>
           <p:cNvSpPr txBox="true"/>
           <p:nvPr/>
         </p:nvSpPr>
@@ -4068,7 +4114,7 @@
       </p:sp>
       <p:sp>
         <p:nvSpPr>
-          <p:cNvPr name="AutoShape 27" id="27"/>
+          <p:cNvPr name="AutoShape 28" id="28"/>
           <p:cNvSpPr/>
           <p:nvPr/>
         </p:nvSpPr>
@@ -4094,7 +4140,7 @@
       </p:sp>
       <p:sp>
         <p:nvSpPr>
-          <p:cNvPr name="Freeform 28" id="28"/>
+          <p:cNvPr name="Freeform 29" id="29"/>
           <p:cNvSpPr/>
           <p:nvPr/>
         </p:nvSpPr>
@@ -4229,7 +4275,7 @@
       </p:sp>
       <p:sp>
         <p:nvSpPr>
-          <p:cNvPr name="GraphCompose Text Line" id="29"/>
+          <p:cNvPr name="GraphCompose Text Line" id="30"/>
           <p:cNvSpPr txBox="true"/>
           <p:nvPr/>
         </p:nvSpPr>
@@ -4275,7 +4321,7 @@
       </p:sp>
       <p:sp>
         <p:nvSpPr>
-          <p:cNvPr name="GraphCompose Text Line" id="30"/>
+          <p:cNvPr name="GraphCompose Text Line" id="31"/>
           <p:cNvSpPr txBox="true"/>
           <p:nvPr/>
         </p:nvSpPr>
@@ -4321,7 +4367,7 @@
       </p:sp>
       <p:sp>
         <p:nvSpPr>
-          <p:cNvPr name="AutoShape 31" id="31"/>
+          <p:cNvPr name="AutoShape 32" id="32"/>
           <p:cNvSpPr/>
           <p:nvPr/>
         </p:nvSpPr>
@@ -4345,7 +4391,7 @@
       </p:sp>
       <p:sp>
         <p:nvSpPr>
-          <p:cNvPr name="AutoShape 32" id="32"/>
+          <p:cNvPr name="AutoShape 33" id="33"/>
           <p:cNvSpPr/>
           <p:nvPr/>
         </p:nvSpPr>
@@ -4369,7 +4415,7 @@
       </p:sp>
       <p:sp>
         <p:nvSpPr>
-          <p:cNvPr name="AutoShape 33" id="33"/>
+          <p:cNvPr name="AutoShape 34" id="34"/>
           <p:cNvSpPr/>
           <p:nvPr/>
         </p:nvSpPr>
@@ -4393,7 +4439,7 @@
       </p:sp>
       <p:sp>
         <p:nvSpPr>
-          <p:cNvPr name="AutoShape 34" id="34"/>
+          <p:cNvPr name="AutoShape 35" id="35"/>
           <p:cNvSpPr/>
           <p:nvPr/>
         </p:nvSpPr>
@@ -4417,7 +4463,7 @@
       </p:sp>
       <p:sp>
         <p:nvSpPr>
-          <p:cNvPr name="AutoShape 35" id="35"/>
+          <p:cNvPr name="AutoShape 36" id="36"/>
           <p:cNvSpPr/>
           <p:nvPr/>
         </p:nvSpPr>
@@ -4439,7 +4485,7 @@
       </p:sp>
       <p:sp>
         <p:nvSpPr>
-          <p:cNvPr name="AutoShape 36" id="36"/>
+          <p:cNvPr name="AutoShape 37" id="37"/>
           <p:cNvSpPr/>
           <p:nvPr/>
         </p:nvSpPr>
@@ -4461,7 +4507,7 @@
       </p:sp>
       <p:sp>
         <p:nvSpPr>
-          <p:cNvPr name="AutoShape 37" id="37"/>
+          <p:cNvPr name="AutoShape 38" id="38"/>
           <p:cNvSpPr/>
           <p:nvPr/>
         </p:nvSpPr>
@@ -4483,7 +4529,7 @@
       </p:sp>
       <p:sp>
         <p:nvSpPr>
-          <p:cNvPr name="AutoShape 38" id="38"/>
+          <p:cNvPr name="AutoShape 39" id="39"/>
           <p:cNvSpPr/>
           <p:nvPr/>
         </p:nvSpPr>
@@ -4511,7 +4557,7 @@
       </p:sp>
       <p:sp>
         <p:nvSpPr>
-          <p:cNvPr name="Freeform 39" id="39"/>
+          <p:cNvPr name="Freeform 40" id="40"/>
           <p:cNvSpPr/>
           <p:nvPr/>
         </p:nvSpPr>
@@ -4569,7 +4615,7 @@
       </p:sp>
       <p:sp>
         <p:nvSpPr>
-          <p:cNvPr name="Freeform 40" id="40"/>
+          <p:cNvPr name="Freeform 41" id="41"/>
           <p:cNvSpPr/>
           <p:nvPr/>
         </p:nvSpPr>
@@ -4627,7 +4673,7 @@
       </p:sp>
       <p:sp>
         <p:nvSpPr>
-          <p:cNvPr name="Freeform 41" id="41"/>
+          <p:cNvPr name="Freeform 42" id="42"/>
           <p:cNvSpPr/>
           <p:nvPr/>
         </p:nvSpPr>
@@ -4892,7 +4938,7 @@
       </p:sp>
       <p:sp>
         <p:nvSpPr>
-          <p:cNvPr name="GraphCompose Text Line" id="42"/>
+          <p:cNvPr name="GraphCompose Text Line" id="43"/>
           <p:cNvSpPr txBox="true"/>
           <p:nvPr/>
         </p:nvSpPr>
@@ -4938,7 +4984,7 @@
       </p:sp>
       <p:sp>
         <p:nvSpPr>
-          <p:cNvPr name="GraphCompose Text Line" id="43"/>
+          <p:cNvPr name="GraphCompose Text Line" id="44"/>
           <p:cNvSpPr txBox="true"/>
           <p:nvPr/>
         </p:nvSpPr>
@@ -4984,7 +5030,7 @@
       </p:sp>
       <p:sp>
         <p:nvSpPr>
-          <p:cNvPr name="GraphCompose Text Line" id="44"/>
+          <p:cNvPr name="GraphCompose Text Line" id="45"/>
           <p:cNvSpPr txBox="true"/>
           <p:nvPr/>
         </p:nvSpPr>
@@ -5030,7 +5076,7 @@
       </p:sp>
       <p:sp>
         <p:nvSpPr>
-          <p:cNvPr name="AutoShape 45" id="45"/>
+          <p:cNvPr name="AutoShape 46" id="46"/>
           <p:cNvSpPr/>
           <p:nvPr/>
         </p:nvSpPr>
@@ -5058,7 +5104,7 @@
       </p:sp>
       <p:sp>
         <p:nvSpPr>
-          <p:cNvPr name="Freeform 46" id="46"/>
+          <p:cNvPr name="Freeform 47" id="47"/>
           <p:cNvSpPr/>
           <p:nvPr/>
         </p:nvSpPr>
@@ -5116,7 +5162,7 @@
       </p:sp>
       <p:sp>
         <p:nvSpPr>
-          <p:cNvPr name="Freeform 47" id="47"/>
+          <p:cNvPr name="Freeform 48" id="48"/>
           <p:cNvSpPr/>
           <p:nvPr/>
         </p:nvSpPr>
@@ -5174,7 +5220,7 @@
       </p:sp>
       <p:sp>
         <p:nvSpPr>
-          <p:cNvPr name="Freeform 48" id="48"/>
+          <p:cNvPr name="Freeform 49" id="49"/>
           <p:cNvSpPr/>
           <p:nvPr/>
         </p:nvSpPr>
@@ -5439,7 +5485,7 @@
       </p:sp>
       <p:sp>
         <p:nvSpPr>
-          <p:cNvPr name="Freeform 49" id="49"/>
+          <p:cNvPr name="Freeform 50" id="50"/>
           <p:cNvSpPr/>
           <p:nvPr/>
         </p:nvSpPr>
@@ -5535,7 +5581,7 @@
       </p:sp>
       <p:sp>
         <p:nvSpPr>
-          <p:cNvPr name="Freeform 50" id="50"/>
+          <p:cNvPr name="Freeform 51" id="51"/>
           <p:cNvSpPr/>
           <p:nvPr/>
         </p:nvSpPr>
@@ -5621,7 +5667,7 @@
       </p:sp>
       <p:sp>
         <p:nvSpPr>
-          <p:cNvPr name="GraphCompose Text Line" id="51"/>
+          <p:cNvPr name="GraphCompose Text Line" id="52"/>
           <p:cNvSpPr txBox="true"/>
           <p:nvPr/>
         </p:nvSpPr>
@@ -5667,7 +5713,7 @@
       </p:sp>
       <p:sp>
         <p:nvSpPr>
-          <p:cNvPr name="GraphCompose Text Line" id="52"/>
+          <p:cNvPr name="GraphCompose Text Line" id="53"/>
           <p:cNvSpPr txBox="true"/>
           <p:nvPr/>
         </p:nvSpPr>
@@ -5713,7 +5759,7 @@
       </p:sp>
       <p:sp>
         <p:nvSpPr>
-          <p:cNvPr name="GraphCompose Text Line" id="53"/>
+          <p:cNvPr name="GraphCompose Text Line" id="54"/>
           <p:cNvSpPr txBox="true"/>
           <p:nvPr/>
         </p:nvSpPr>
@@ -5759,14 +5805,14 @@
       </p:sp>
       <p:sp>
         <p:nvSpPr>
-          <p:cNvPr name="GraphCompose Text Line" id="54"/>
+          <p:cNvPr name="GraphCompose Text Line" id="55"/>
           <p:cNvSpPr txBox="true"/>
           <p:nvPr/>
         </p:nvSpPr>
         <p:spPr>
           <a:xfrm>
             <a:off x="7899400" y="5032481"/>
-            <a:ext cx="2423352" cy="109252"/>
+            <a:ext cx="2547840" cy="109252"/>
           </a:xfrm>
           <a:prstGeom prst="rect">
             <a:avLst/>
@@ -5797,7 +5843,7 @@
                 </a:solidFill>
                 <a:latin typeface="Arial"/>
               </a:rPr>
-              <a:t>same coordinates - same fonts - same colours</a:t>
+              <a:t>same coordinates - same metrics - same colours</a:t>
             </a:r>
             <a:endParaRPr lang="en-US" sz="1100"/>
           </a:p>
@@ -5805,7 +5851,7 @@
       </p:sp>
       <p:sp>
         <p:nvSpPr>
-          <p:cNvPr name="AutoShape 55" id="55"/>
+          <p:cNvPr name="AutoShape 56" id="56"/>
           <p:cNvSpPr/>
           <p:nvPr/>
         </p:nvSpPr>
@@ -5833,7 +5879,7 @@
       </p:sp>
       <p:sp>
         <p:nvSpPr>
-          <p:cNvPr name="AutoShape 56" id="56"/>
+          <p:cNvPr name="AutoShape 57" id="57"/>
           <p:cNvSpPr/>
           <p:nvPr/>
         </p:nvSpPr>
@@ -5855,7 +5901,7 @@
       </p:sp>
       <p:sp>
         <p:nvSpPr>
-          <p:cNvPr name="GraphCompose Text Line" id="57"/>
+          <p:cNvPr name="GraphCompose Text Line" id="58"/>
           <p:cNvSpPr txBox="true"/>
           <p:nvPr/>
         </p:nvSpPr>
@@ -5901,7 +5947,7 @@
       </p:sp>
       <p:sp>
         <p:nvSpPr>
-          <p:cNvPr name="GraphCompose Text Line" id="58"/>
+          <p:cNvPr name="GraphCompose Text Line" id="59"/>
           <p:cNvSpPr txBox="true"/>
           <p:nvPr/>
         </p:nvSpPr>
@@ -5947,7 +5993,7 @@
       </p:sp>
       <p:sp>
         <p:nvSpPr>
-          <p:cNvPr name="AutoShape 59" id="59"/>
+          <p:cNvPr name="AutoShape 60" id="60"/>
           <p:cNvSpPr/>
           <p:nvPr/>
         </p:nvSpPr>
@@ -5975,7 +6021,7 @@
       </p:sp>
       <p:sp>
         <p:nvSpPr>
-          <p:cNvPr name="AutoShape 60" id="60"/>
+          <p:cNvPr name="AutoShape 61" id="61"/>
           <p:cNvSpPr/>
           <p:nvPr/>
         </p:nvSpPr>
@@ -5997,7 +6043,7 @@
       </p:sp>
       <p:sp>
         <p:nvSpPr>
-          <p:cNvPr name="GraphCompose Text Line" id="61"/>
+          <p:cNvPr name="GraphCompose Text Line" id="62"/>
           <p:cNvSpPr txBox="true"/>
           <p:nvPr/>
         </p:nvSpPr>
@@ -6043,7 +6089,7 @@
       </p:sp>
       <p:sp>
         <p:nvSpPr>
-          <p:cNvPr name="GraphCompose Text Line" id="62"/>
+          <p:cNvPr name="GraphCompose Text Line" id="63"/>
           <p:cNvSpPr txBox="true"/>
           <p:nvPr/>
         </p:nvSpPr>
@@ -6089,7 +6135,7 @@
       </p:sp>
       <p:sp>
         <p:nvSpPr>
-          <p:cNvPr name="AutoShape 63" id="63"/>
+          <p:cNvPr name="AutoShape 64" id="64"/>
           <p:cNvSpPr/>
           <p:nvPr/>
         </p:nvSpPr>
@@ -6117,7 +6163,7 @@
       </p:sp>
       <p:sp>
         <p:nvSpPr>
-          <p:cNvPr name="AutoShape 64" id="64"/>
+          <p:cNvPr name="AutoShape 65" id="65"/>
           <p:cNvSpPr/>
           <p:nvPr/>
         </p:nvSpPr>
@@ -6139,7 +6185,7 @@
       </p:sp>
       <p:sp>
         <p:nvSpPr>
-          <p:cNvPr name="GraphCompose Text Line" id="65"/>
+          <p:cNvPr name="GraphCompose Text Line" id="66"/>
           <p:cNvSpPr txBox="true"/>
           <p:nvPr/>
         </p:nvSpPr>
@@ -6185,7 +6231,7 @@
       </p:sp>
       <p:sp>
         <p:nvSpPr>
-          <p:cNvPr name="GraphCompose Text Line" id="66"/>
+          <p:cNvPr name="GraphCompose Text Line" id="67"/>
           <p:cNvSpPr txBox="true"/>
           <p:nvPr/>
         </p:nvSpPr>
@@ -6231,7 +6277,7 @@
       </p:sp>
       <p:sp>
         <p:nvSpPr>
-          <p:cNvPr name="AutoShape 67" id="67"/>
+          <p:cNvPr name="AutoShape 68" id="68"/>
           <p:cNvSpPr/>
           <p:nvPr/>
         </p:nvSpPr>
@@ -6259,7 +6305,7 @@
       </p:sp>
       <p:sp>
         <p:nvSpPr>
-          <p:cNvPr name="AutoShape 68" id="68"/>
+          <p:cNvPr name="AutoShape 69" id="69"/>
           <p:cNvSpPr/>
           <p:nvPr/>
         </p:nvSpPr>
@@ -6281,7 +6327,7 @@
       </p:sp>
       <p:sp>
         <p:nvSpPr>
-          <p:cNvPr name="GraphCompose Text Line" id="69"/>
+          <p:cNvPr name="GraphCompose Text Line" id="70"/>
           <p:cNvSpPr txBox="true"/>
           <p:nvPr/>
         </p:nvSpPr>
@@ -6327,7 +6373,7 @@
       </p:sp>
       <p:sp>
         <p:nvSpPr>
-          <p:cNvPr name="GraphCompose Text Line" id="70"/>
+          <p:cNvPr name="GraphCompose Text Line" id="71"/>
           <p:cNvSpPr txBox="true"/>
           <p:nvPr/>
         </p:nvSpPr>

</xml_diff>

<commit_message>
docs(examples): syntax-highlight the twin-output code card with styled inline runs
</commit_message>
<xml_diff>
--- a/assets/readme/examples/twin-output.pptx
+++ b/assets/readme/examples/twin-output.pptx
@@ -3550,11 +3550,92 @@
             <a:r>
               <a:rPr lang="en-US" sz="950" b="false" i="false" u="none" strike="noStrike" kern="0">
                 <a:solidFill>
-                  <a:srgbClr val="BEC3D6"/>
+                  <a:srgbClr val="96BEFF"/>
                 </a:solidFill>
                 <a:latin typeface="Courier New"/>
               </a:rPr>
-              <a:t>Path deck = Path.of("twin-output.pptx");</a:t>
+              <a:t>Path</a:t>
+            </a:r>
+            <a:r>
+              <a:rPr lang="en-US" sz="950" b="false" i="false" u="none" strike="noStrike" kern="0">
+                <a:solidFill>
+                  <a:srgbClr val="BEC3D6"/>
+                </a:solidFill>
+                <a:latin typeface="Courier New"/>
+              </a:rPr>
+              <a:t> </a:t>
+            </a:r>
+            <a:r>
+              <a:rPr lang="en-US" sz="950" b="false" i="false" u="none" strike="noStrike" kern="0">
+                <a:solidFill>
+                  <a:srgbClr val="BEC3D6"/>
+                </a:solidFill>
+                <a:latin typeface="Courier New"/>
+              </a:rPr>
+              <a:t>deck</a:t>
+            </a:r>
+            <a:r>
+              <a:rPr lang="en-US" sz="950" b="false" i="false" u="none" strike="noStrike" kern="0">
+                <a:solidFill>
+                  <a:srgbClr val="BEC3D6"/>
+                </a:solidFill>
+                <a:latin typeface="Courier New"/>
+              </a:rPr>
+              <a:t> </a:t>
+            </a:r>
+            <a:r>
+              <a:rPr lang="en-US" sz="950" b="false" i="false" u="none" strike="noStrike" kern="0">
+                <a:solidFill>
+                  <a:srgbClr val="BEC3D6"/>
+                </a:solidFill>
+                <a:latin typeface="Courier New"/>
+              </a:rPr>
+              <a:t>=</a:t>
+            </a:r>
+            <a:r>
+              <a:rPr lang="en-US" sz="950" b="false" i="false" u="none" strike="noStrike" kern="0">
+                <a:solidFill>
+                  <a:srgbClr val="BEC3D6"/>
+                </a:solidFill>
+                <a:latin typeface="Courier New"/>
+              </a:rPr>
+              <a:t> </a:t>
+            </a:r>
+            <a:r>
+              <a:rPr lang="en-US" sz="950" b="false" i="false" u="none" strike="noStrike" kern="0">
+                <a:solidFill>
+                  <a:srgbClr val="96BEFF"/>
+                </a:solidFill>
+                <a:latin typeface="Courier New"/>
+              </a:rPr>
+              <a:t>Path</a:t>
+            </a:r>
+            <a:r>
+              <a:rPr lang="en-US" sz="950" b="false" i="false" u="none" strike="noStrike" kern="0">
+                <a:solidFill>
+                  <a:srgbClr val="BEC3D6"/>
+                </a:solidFill>
+                <a:latin typeface="Courier New"/>
+              </a:rPr>
+              <a:t>.of(</a:t>
+            </a:r>
+            <a:r>
+              <a:rPr lang="en-US" sz="950" b="false" i="false" u="none" strike="noStrike" kern="0">
+                <a:solidFill>
+                  <a:srgbClr val="78CCAA"/>
+                </a:solidFill>
+                <a:latin typeface="Courier New"/>
+              </a:rPr>
+              <a:t>"twin-output.pptx"</a:t>
+            </a:r>
+            <a:r>
+              <a:rPr lang="en-US" sz="950" b="false" i="false" u="none" strike="noStrike" kern="0">
+                <a:solidFill>
+                  <a:srgbClr val="BEC3D6"/>
+                </a:solidFill>
+                <a:latin typeface="Courier New"/>
+              </a:rPr>
+              <a:t>);</a:t>
             </a:r>
             <a:endParaRPr lang="en-US" sz="1100"/>
           </a:p>
@@ -3596,11 +3677,92 @@
             <a:r>
               <a:rPr lang="en-US" sz="950" b="false" i="false" u="none" strike="noStrike" kern="0">
                 <a:solidFill>
-                  <a:srgbClr val="BEC3D6"/>
+                  <a:srgbClr val="B59FFF"/>
                 </a:solidFill>
                 <a:latin typeface="Courier New"/>
               </a:rPr>
-              <a:t>try (DocumentSession doc = GraphCompose</a:t>
+              <a:t>try</a:t>
+            </a:r>
+            <a:r>
+              <a:rPr lang="en-US" sz="950" b="false" i="false" u="none" strike="noStrike" kern="0">
+                <a:solidFill>
+                  <a:srgbClr val="BEC3D6"/>
+                </a:solidFill>
+                <a:latin typeface="Courier New"/>
+              </a:rPr>
+              <a:t> </a:t>
+            </a:r>
+            <a:r>
+              <a:rPr lang="en-US" sz="950" b="false" i="false" u="none" strike="noStrike" kern="0">
+                <a:solidFill>
+                  <a:srgbClr val="BEC3D6"/>
+                </a:solidFill>
+                <a:latin typeface="Courier New"/>
+              </a:rPr>
+              <a:t>(</a:t>
+            </a:r>
+            <a:r>
+              <a:rPr lang="en-US" sz="950" b="false" i="false" u="none" strike="noStrike" kern="0">
+                <a:solidFill>
+                  <a:srgbClr val="96BEFF"/>
+                </a:solidFill>
+                <a:latin typeface="Courier New"/>
+              </a:rPr>
+              <a:t>DocumentSession</a:t>
+            </a:r>
+            <a:r>
+              <a:rPr lang="en-US" sz="950" b="false" i="false" u="none" strike="noStrike" kern="0">
+                <a:solidFill>
+                  <a:srgbClr val="BEC3D6"/>
+                </a:solidFill>
+                <a:latin typeface="Courier New"/>
+              </a:rPr>
+              <a:t> </a:t>
+            </a:r>
+            <a:r>
+              <a:rPr lang="en-US" sz="950" b="false" i="false" u="none" strike="noStrike" kern="0">
+                <a:solidFill>
+                  <a:srgbClr val="BEC3D6"/>
+                </a:solidFill>
+                <a:latin typeface="Courier New"/>
+              </a:rPr>
+              <a:t>doc</a:t>
+            </a:r>
+            <a:r>
+              <a:rPr lang="en-US" sz="950" b="false" i="false" u="none" strike="noStrike" kern="0">
+                <a:solidFill>
+                  <a:srgbClr val="BEC3D6"/>
+                </a:solidFill>
+                <a:latin typeface="Courier New"/>
+              </a:rPr>
+              <a:t> </a:t>
+            </a:r>
+            <a:r>
+              <a:rPr lang="en-US" sz="950" b="false" i="false" u="none" strike="noStrike" kern="0">
+                <a:solidFill>
+                  <a:srgbClr val="BEC3D6"/>
+                </a:solidFill>
+                <a:latin typeface="Courier New"/>
+              </a:rPr>
+              <a:t>=</a:t>
+            </a:r>
+            <a:r>
+              <a:rPr lang="en-US" sz="950" b="false" i="false" u="none" strike="noStrike" kern="0">
+                <a:solidFill>
+                  <a:srgbClr val="BEC3D6"/>
+                </a:solidFill>
+                <a:latin typeface="Courier New"/>
+              </a:rPr>
+              <a:t> </a:t>
+            </a:r>
+            <a:r>
+              <a:rPr lang="en-US" sz="950" b="false" i="false" u="none" strike="noStrike" kern="0">
+                <a:solidFill>
+                  <a:srgbClr val="96BEFF"/>
+                </a:solidFill>
+                <a:latin typeface="Courier New"/>
+              </a:rPr>
+              <a:t>GraphCompose</a:t>
             </a:r>
             <a:endParaRPr lang="en-US" sz="1100"/>
           </a:p>
@@ -3646,7 +3808,43 @@
                 </a:solidFill>
                 <a:latin typeface="Courier New"/>
               </a:rPr>
-              <a:t>.document(Path.of("twin-output.pdf"))</a:t>
+              <a:t>.document(</a:t>
+            </a:r>
+            <a:r>
+              <a:rPr lang="en-US" sz="950" b="false" i="false" u="none" strike="noStrike" kern="0">
+                <a:solidFill>
+                  <a:srgbClr val="96BEFF"/>
+                </a:solidFill>
+                <a:latin typeface="Courier New"/>
+              </a:rPr>
+              <a:t>Path</a:t>
+            </a:r>
+            <a:r>
+              <a:rPr lang="en-US" sz="950" b="false" i="false" u="none" strike="noStrike" kern="0">
+                <a:solidFill>
+                  <a:srgbClr val="BEC3D6"/>
+                </a:solidFill>
+                <a:latin typeface="Courier New"/>
+              </a:rPr>
+              <a:t>.of(</a:t>
+            </a:r>
+            <a:r>
+              <a:rPr lang="en-US" sz="950" b="false" i="false" u="none" strike="noStrike" kern="0">
+                <a:solidFill>
+                  <a:srgbClr val="78CCAA"/>
+                </a:solidFill>
+                <a:latin typeface="Courier New"/>
+              </a:rPr>
+              <a:t>"twin-output.pdf"</a:t>
+            </a:r>
+            <a:r>
+              <a:rPr lang="en-US" sz="950" b="false" i="false" u="none" strike="noStrike" kern="0">
+                <a:solidFill>
+                  <a:srgbClr val="BEC3D6"/>
+                </a:solidFill>
+                <a:latin typeface="Courier New"/>
+              </a:rPr>
+              <a:t>))</a:t>
             </a:r>
             <a:endParaRPr lang="en-US" sz="1100"/>
           </a:p>
@@ -3692,7 +3890,25 @@
                 </a:solidFill>
                 <a:latin typeface="Courier New"/>
               </a:rPr>
-              <a:t>.pageSize(DocumentPageSize.SLIDE_16_9)</a:t>
+              <a:t>.pageSize(</a:t>
+            </a:r>
+            <a:r>
+              <a:rPr lang="en-US" sz="950" b="false" i="false" u="none" strike="noStrike" kern="0">
+                <a:solidFill>
+                  <a:srgbClr val="96BEFF"/>
+                </a:solidFill>
+                <a:latin typeface="Courier New"/>
+              </a:rPr>
+              <a:t>DocumentPageSize</a:t>
+            </a:r>
+            <a:r>
+              <a:rPr lang="en-US" sz="950" b="false" i="false" u="none" strike="noStrike" kern="0">
+                <a:solidFill>
+                  <a:srgbClr val="BEC3D6"/>
+                </a:solidFill>
+                <a:latin typeface="Courier New"/>
+              </a:rPr>
+              <a:t>.SLIDE_16_9)</a:t>
             </a:r>
             <a:endParaRPr lang="en-US" sz="1100"/>
           </a:p>
@@ -3738,7 +3954,25 @@
                 </a:solidFill>
                 <a:latin typeface="Courier New"/>
               </a:rPr>
-              <a:t>.create()) {</a:t>
+              <a:t>.create())</a:t>
+            </a:r>
+            <a:r>
+              <a:rPr lang="en-US" sz="950" b="false" i="false" u="none" strike="noStrike" kern="0">
+                <a:solidFill>
+                  <a:srgbClr val="BEC3D6"/>
+                </a:solidFill>
+                <a:latin typeface="Courier New"/>
+              </a:rPr>
+              <a:t> </a:t>
+            </a:r>
+            <a:r>
+              <a:rPr lang="en-US" sz="950" b="false" i="false" u="none" strike="noStrike" kern="0">
+                <a:solidFill>
+                  <a:srgbClr val="BEC3D6"/>
+                </a:solidFill>
+                <a:latin typeface="Courier New"/>
+              </a:rPr>
+              <a:t>{</a:t>
             </a:r>
             <a:endParaRPr lang="en-US" sz="1100"/>
           </a:p>
@@ -3876,7 +4110,25 @@
                 </a:solidFill>
                 <a:latin typeface="Courier New"/>
               </a:rPr>
-              <a:t>doc.buildPdf();</a:t>
+              <a:t>doc.</a:t>
+            </a:r>
+            <a:r>
+              <a:rPr lang="en-US" sz="950" b="false" i="false" u="none" strike="noStrike" kern="0">
+                <a:solidFill>
+                  <a:srgbClr val="B59FFF"/>
+                </a:solidFill>
+                <a:latin typeface="Courier New"/>
+              </a:rPr>
+              <a:t>buildPdf</a:t>
+            </a:r>
+            <a:r>
+              <a:rPr lang="en-US" sz="950" b="false" i="false" u="none" strike="noStrike" kern="0">
+                <a:solidFill>
+                  <a:srgbClr val="BEC3D6"/>
+                </a:solidFill>
+                <a:latin typeface="Courier New"/>
+              </a:rPr>
+              <a:t>();</a:t>
             </a:r>
             <a:endParaRPr lang="en-US" sz="1100"/>
           </a:p>
@@ -3968,7 +4220,25 @@
                 </a:solidFill>
                 <a:latin typeface="Courier New"/>
               </a:rPr>
-              <a:t>doc.buildPptx(deck);</a:t>
+              <a:t>doc.</a:t>
+            </a:r>
+            <a:r>
+              <a:rPr lang="en-US" sz="950" b="false" i="false" u="none" strike="noStrike" kern="0">
+                <a:solidFill>
+                  <a:srgbClr val="B59FFF"/>
+                </a:solidFill>
+                <a:latin typeface="Courier New"/>
+              </a:rPr>
+              <a:t>buildPptx</a:t>
+            </a:r>
+            <a:r>
+              <a:rPr lang="en-US" sz="950" b="false" i="false" u="none" strike="noStrike" kern="0">
+                <a:solidFill>
+                  <a:srgbClr val="BEC3D6"/>
+                </a:solidFill>
+                <a:latin typeface="Courier New"/>
+              </a:rPr>
+              <a:t>(deck);</a:t>
             </a:r>
             <a:endParaRPr lang="en-US" sz="1100"/>
           </a:p>

</xml_diff>

<commit_message>
docs(examples): syntax-highlight the twin-output code card with styled inline runs (#430)
</commit_message>
<xml_diff>
--- a/assets/readme/examples/twin-output.pptx
+++ b/assets/readme/examples/twin-output.pptx
@@ -3550,11 +3550,92 @@
             <a:r>
               <a:rPr lang="en-US" sz="950" b="false" i="false" u="none" strike="noStrike" kern="0">
                 <a:solidFill>
-                  <a:srgbClr val="BEC3D6"/>
+                  <a:srgbClr val="96BEFF"/>
                 </a:solidFill>
                 <a:latin typeface="Courier New"/>
               </a:rPr>
-              <a:t>Path deck = Path.of("twin-output.pptx");</a:t>
+              <a:t>Path</a:t>
+            </a:r>
+            <a:r>
+              <a:rPr lang="en-US" sz="950" b="false" i="false" u="none" strike="noStrike" kern="0">
+                <a:solidFill>
+                  <a:srgbClr val="BEC3D6"/>
+                </a:solidFill>
+                <a:latin typeface="Courier New"/>
+              </a:rPr>
+              <a:t> </a:t>
+            </a:r>
+            <a:r>
+              <a:rPr lang="en-US" sz="950" b="false" i="false" u="none" strike="noStrike" kern="0">
+                <a:solidFill>
+                  <a:srgbClr val="BEC3D6"/>
+                </a:solidFill>
+                <a:latin typeface="Courier New"/>
+              </a:rPr>
+              <a:t>deck</a:t>
+            </a:r>
+            <a:r>
+              <a:rPr lang="en-US" sz="950" b="false" i="false" u="none" strike="noStrike" kern="0">
+                <a:solidFill>
+                  <a:srgbClr val="BEC3D6"/>
+                </a:solidFill>
+                <a:latin typeface="Courier New"/>
+              </a:rPr>
+              <a:t> </a:t>
+            </a:r>
+            <a:r>
+              <a:rPr lang="en-US" sz="950" b="false" i="false" u="none" strike="noStrike" kern="0">
+                <a:solidFill>
+                  <a:srgbClr val="BEC3D6"/>
+                </a:solidFill>
+                <a:latin typeface="Courier New"/>
+              </a:rPr>
+              <a:t>=</a:t>
+            </a:r>
+            <a:r>
+              <a:rPr lang="en-US" sz="950" b="false" i="false" u="none" strike="noStrike" kern="0">
+                <a:solidFill>
+                  <a:srgbClr val="BEC3D6"/>
+                </a:solidFill>
+                <a:latin typeface="Courier New"/>
+              </a:rPr>
+              <a:t> </a:t>
+            </a:r>
+            <a:r>
+              <a:rPr lang="en-US" sz="950" b="false" i="false" u="none" strike="noStrike" kern="0">
+                <a:solidFill>
+                  <a:srgbClr val="96BEFF"/>
+                </a:solidFill>
+                <a:latin typeface="Courier New"/>
+              </a:rPr>
+              <a:t>Path</a:t>
+            </a:r>
+            <a:r>
+              <a:rPr lang="en-US" sz="950" b="false" i="false" u="none" strike="noStrike" kern="0">
+                <a:solidFill>
+                  <a:srgbClr val="BEC3D6"/>
+                </a:solidFill>
+                <a:latin typeface="Courier New"/>
+              </a:rPr>
+              <a:t>.of(</a:t>
+            </a:r>
+            <a:r>
+              <a:rPr lang="en-US" sz="950" b="false" i="false" u="none" strike="noStrike" kern="0">
+                <a:solidFill>
+                  <a:srgbClr val="78CCAA"/>
+                </a:solidFill>
+                <a:latin typeface="Courier New"/>
+              </a:rPr>
+              <a:t>"twin-output.pptx"</a:t>
+            </a:r>
+            <a:r>
+              <a:rPr lang="en-US" sz="950" b="false" i="false" u="none" strike="noStrike" kern="0">
+                <a:solidFill>
+                  <a:srgbClr val="BEC3D6"/>
+                </a:solidFill>
+                <a:latin typeface="Courier New"/>
+              </a:rPr>
+              <a:t>);</a:t>
             </a:r>
             <a:endParaRPr lang="en-US" sz="1100"/>
           </a:p>
@@ -3596,11 +3677,92 @@
             <a:r>
               <a:rPr lang="en-US" sz="950" b="false" i="false" u="none" strike="noStrike" kern="0">
                 <a:solidFill>
-                  <a:srgbClr val="BEC3D6"/>
+                  <a:srgbClr val="B59FFF"/>
                 </a:solidFill>
                 <a:latin typeface="Courier New"/>
               </a:rPr>
-              <a:t>try (DocumentSession doc = GraphCompose</a:t>
+              <a:t>try</a:t>
+            </a:r>
+            <a:r>
+              <a:rPr lang="en-US" sz="950" b="false" i="false" u="none" strike="noStrike" kern="0">
+                <a:solidFill>
+                  <a:srgbClr val="BEC3D6"/>
+                </a:solidFill>
+                <a:latin typeface="Courier New"/>
+              </a:rPr>
+              <a:t> </a:t>
+            </a:r>
+            <a:r>
+              <a:rPr lang="en-US" sz="950" b="false" i="false" u="none" strike="noStrike" kern="0">
+                <a:solidFill>
+                  <a:srgbClr val="BEC3D6"/>
+                </a:solidFill>
+                <a:latin typeface="Courier New"/>
+              </a:rPr>
+              <a:t>(</a:t>
+            </a:r>
+            <a:r>
+              <a:rPr lang="en-US" sz="950" b="false" i="false" u="none" strike="noStrike" kern="0">
+                <a:solidFill>
+                  <a:srgbClr val="96BEFF"/>
+                </a:solidFill>
+                <a:latin typeface="Courier New"/>
+              </a:rPr>
+              <a:t>DocumentSession</a:t>
+            </a:r>
+            <a:r>
+              <a:rPr lang="en-US" sz="950" b="false" i="false" u="none" strike="noStrike" kern="0">
+                <a:solidFill>
+                  <a:srgbClr val="BEC3D6"/>
+                </a:solidFill>
+                <a:latin typeface="Courier New"/>
+              </a:rPr>
+              <a:t> </a:t>
+            </a:r>
+            <a:r>
+              <a:rPr lang="en-US" sz="950" b="false" i="false" u="none" strike="noStrike" kern="0">
+                <a:solidFill>
+                  <a:srgbClr val="BEC3D6"/>
+                </a:solidFill>
+                <a:latin typeface="Courier New"/>
+              </a:rPr>
+              <a:t>doc</a:t>
+            </a:r>
+            <a:r>
+              <a:rPr lang="en-US" sz="950" b="false" i="false" u="none" strike="noStrike" kern="0">
+                <a:solidFill>
+                  <a:srgbClr val="BEC3D6"/>
+                </a:solidFill>
+                <a:latin typeface="Courier New"/>
+              </a:rPr>
+              <a:t> </a:t>
+            </a:r>
+            <a:r>
+              <a:rPr lang="en-US" sz="950" b="false" i="false" u="none" strike="noStrike" kern="0">
+                <a:solidFill>
+                  <a:srgbClr val="BEC3D6"/>
+                </a:solidFill>
+                <a:latin typeface="Courier New"/>
+              </a:rPr>
+              <a:t>=</a:t>
+            </a:r>
+            <a:r>
+              <a:rPr lang="en-US" sz="950" b="false" i="false" u="none" strike="noStrike" kern="0">
+                <a:solidFill>
+                  <a:srgbClr val="BEC3D6"/>
+                </a:solidFill>
+                <a:latin typeface="Courier New"/>
+              </a:rPr>
+              <a:t> </a:t>
+            </a:r>
+            <a:r>
+              <a:rPr lang="en-US" sz="950" b="false" i="false" u="none" strike="noStrike" kern="0">
+                <a:solidFill>
+                  <a:srgbClr val="96BEFF"/>
+                </a:solidFill>
+                <a:latin typeface="Courier New"/>
+              </a:rPr>
+              <a:t>GraphCompose</a:t>
             </a:r>
             <a:endParaRPr lang="en-US" sz="1100"/>
           </a:p>
@@ -3646,7 +3808,43 @@
                 </a:solidFill>
                 <a:latin typeface="Courier New"/>
               </a:rPr>
-              <a:t>.document(Path.of("twin-output.pdf"))</a:t>
+              <a:t>.document(</a:t>
+            </a:r>
+            <a:r>
+              <a:rPr lang="en-US" sz="950" b="false" i="false" u="none" strike="noStrike" kern="0">
+                <a:solidFill>
+                  <a:srgbClr val="96BEFF"/>
+                </a:solidFill>
+                <a:latin typeface="Courier New"/>
+              </a:rPr>
+              <a:t>Path</a:t>
+            </a:r>
+            <a:r>
+              <a:rPr lang="en-US" sz="950" b="false" i="false" u="none" strike="noStrike" kern="0">
+                <a:solidFill>
+                  <a:srgbClr val="BEC3D6"/>
+                </a:solidFill>
+                <a:latin typeface="Courier New"/>
+              </a:rPr>
+              <a:t>.of(</a:t>
+            </a:r>
+            <a:r>
+              <a:rPr lang="en-US" sz="950" b="false" i="false" u="none" strike="noStrike" kern="0">
+                <a:solidFill>
+                  <a:srgbClr val="78CCAA"/>
+                </a:solidFill>
+                <a:latin typeface="Courier New"/>
+              </a:rPr>
+              <a:t>"twin-output.pdf"</a:t>
+            </a:r>
+            <a:r>
+              <a:rPr lang="en-US" sz="950" b="false" i="false" u="none" strike="noStrike" kern="0">
+                <a:solidFill>
+                  <a:srgbClr val="BEC3D6"/>
+                </a:solidFill>
+                <a:latin typeface="Courier New"/>
+              </a:rPr>
+              <a:t>))</a:t>
             </a:r>
             <a:endParaRPr lang="en-US" sz="1100"/>
           </a:p>
@@ -3692,7 +3890,25 @@
                 </a:solidFill>
                 <a:latin typeface="Courier New"/>
               </a:rPr>
-              <a:t>.pageSize(DocumentPageSize.SLIDE_16_9)</a:t>
+              <a:t>.pageSize(</a:t>
+            </a:r>
+            <a:r>
+              <a:rPr lang="en-US" sz="950" b="false" i="false" u="none" strike="noStrike" kern="0">
+                <a:solidFill>
+                  <a:srgbClr val="96BEFF"/>
+                </a:solidFill>
+                <a:latin typeface="Courier New"/>
+              </a:rPr>
+              <a:t>DocumentPageSize</a:t>
+            </a:r>
+            <a:r>
+              <a:rPr lang="en-US" sz="950" b="false" i="false" u="none" strike="noStrike" kern="0">
+                <a:solidFill>
+                  <a:srgbClr val="BEC3D6"/>
+                </a:solidFill>
+                <a:latin typeface="Courier New"/>
+              </a:rPr>
+              <a:t>.SLIDE_16_9)</a:t>
             </a:r>
             <a:endParaRPr lang="en-US" sz="1100"/>
           </a:p>
@@ -3738,7 +3954,25 @@
                 </a:solidFill>
                 <a:latin typeface="Courier New"/>
               </a:rPr>
-              <a:t>.create()) {</a:t>
+              <a:t>.create())</a:t>
+            </a:r>
+            <a:r>
+              <a:rPr lang="en-US" sz="950" b="false" i="false" u="none" strike="noStrike" kern="0">
+                <a:solidFill>
+                  <a:srgbClr val="BEC3D6"/>
+                </a:solidFill>
+                <a:latin typeface="Courier New"/>
+              </a:rPr>
+              <a:t> </a:t>
+            </a:r>
+            <a:r>
+              <a:rPr lang="en-US" sz="950" b="false" i="false" u="none" strike="noStrike" kern="0">
+                <a:solidFill>
+                  <a:srgbClr val="BEC3D6"/>
+                </a:solidFill>
+                <a:latin typeface="Courier New"/>
+              </a:rPr>
+              <a:t>{</a:t>
             </a:r>
             <a:endParaRPr lang="en-US" sz="1100"/>
           </a:p>
@@ -3876,7 +4110,25 @@
                 </a:solidFill>
                 <a:latin typeface="Courier New"/>
               </a:rPr>
-              <a:t>doc.buildPdf();</a:t>
+              <a:t>doc.</a:t>
+            </a:r>
+            <a:r>
+              <a:rPr lang="en-US" sz="950" b="false" i="false" u="none" strike="noStrike" kern="0">
+                <a:solidFill>
+                  <a:srgbClr val="B59FFF"/>
+                </a:solidFill>
+                <a:latin typeface="Courier New"/>
+              </a:rPr>
+              <a:t>buildPdf</a:t>
+            </a:r>
+            <a:r>
+              <a:rPr lang="en-US" sz="950" b="false" i="false" u="none" strike="noStrike" kern="0">
+                <a:solidFill>
+                  <a:srgbClr val="BEC3D6"/>
+                </a:solidFill>
+                <a:latin typeface="Courier New"/>
+              </a:rPr>
+              <a:t>();</a:t>
             </a:r>
             <a:endParaRPr lang="en-US" sz="1100"/>
           </a:p>
@@ -3968,7 +4220,25 @@
                 </a:solidFill>
                 <a:latin typeface="Courier New"/>
               </a:rPr>
-              <a:t>doc.buildPptx(deck);</a:t>
+              <a:t>doc.</a:t>
+            </a:r>
+            <a:r>
+              <a:rPr lang="en-US" sz="950" b="false" i="false" u="none" strike="noStrike" kern="0">
+                <a:solidFill>
+                  <a:srgbClr val="B59FFF"/>
+                </a:solidFill>
+                <a:latin typeface="Courier New"/>
+              </a:rPr>
+              <a:t>buildPptx</a:t>
+            </a:r>
+            <a:r>
+              <a:rPr lang="en-US" sz="950" b="false" i="false" u="none" strike="noStrike" kern="0">
+                <a:solidFill>
+                  <a:srgbClr val="BEC3D6"/>
+                </a:solidFill>
+                <a:latin typeface="Courier New"/>
+              </a:rPr>
+              <a:t>(deck);</a:t>
             </a:r>
             <a:endParaRPr lang="en-US" sz="1100"/>
           </a:p>

</xml_diff>